<commit_message>
Update primitives: Things/Tags/Tools → Notes/Tags/Links
Co-Authored-By: Claude Opus 4.6 (1M context) <noreply@anthropic.com>
</commit_message>
<xml_diff>
--- a/nvc-pitch-deck.pptx
+++ b/nvc-pitch-deck.pptx
@@ -4481,7 +4481,7 @@
             </a:r>
             <a:br/>
             <a:r>
-              <a:t>Things, Tags, and Tools.</a:t>
+              <a:t>Notes, Tags, and Links.</a:t>
             </a:r>
           </a:p>
         </p:txBody>
@@ -4849,7 +4849,7 @@
               </a:defRPr>
             </a:pPr>
             <a:r>
-              <a:t>Parachute Server — Things · Tags · Tools</a:t>
+              <a:t>Parachute Server — Notes · Tags · Links</a:t>
             </a:r>
           </a:p>
         </p:txBody>
@@ -8504,7 +8504,7 @@
               </a:defRPr>
             </a:pPr>
             <a:r>
-              <a:t>MCP server with Things, Tags, Tools architecture</a:t>
+              <a:t>MCP server with Notes, Tags, Links architecture</a:t>
             </a:r>
           </a:p>
         </p:txBody>

</xml_diff>